<commit_message>
Replace "lecture" with "seminar" in slides and handouts
Co-Authored-By: Claude Opus 5.5 <noreply@anthropic.com>
Claude-Session: https://claude.ai/code/session_01XYJ4xmrADRJAP7ufCAYieX
</commit_message>
<xml_diff>
--- a/management-seminars/week01_course_overview.pptx
+++ b/management-seminars/week01_course_overview.pptx
@@ -506,7 +506,7 @@
           <a:lstStyle/>
           <a:p>
             <a:r>
-              <a:t>Management seminar for week 1: Course Overview. We will go through what the course covers, the four lecture types, how the labs work, and the course arc. Provide opening remarks here.</a:t>
+              <a:t>Management seminar for week 1: Course Overview. We will go through what the course covers, the four seminar types, how the labs work, and the course arc. Provide opening remarks here.</a:t>
             </a:r>
           </a:p>
         </p:txBody>
@@ -1506,7 +1506,7 @@
 </p:sldMaster>
 </file>
 
-<file path=ppt/slides/slide11.xml><?xml version="1.0" encoding="utf-8"?>
+<file path=ppt/slides/slide1.xml><?xml version="1.0" encoding="utf-8"?>
 <p:sld xmlns:a="http://schemas.openxmlformats.org/drawingml/2006/main" xmlns:p="http://schemas.openxmlformats.org/presentationml/2006/main" xmlns:r="http://schemas.openxmlformats.org/officeDocument/2006/relationships">
   <p:cSld>
     <p:spTree>
@@ -1600,7 +1600,7 @@
 </p:sld>
 </file>
 
-<file path=ppt/slides/slide12.xml><?xml version="1.0" encoding="utf-8"?>
+<file path=ppt/slides/slide2.xml><?xml version="1.0" encoding="utf-8"?>
 <p:sld xmlns:a="http://schemas.openxmlformats.org/drawingml/2006/main" xmlns:p="http://schemas.openxmlformats.org/presentationml/2006/main" xmlns:r="http://schemas.openxmlformats.org/officeDocument/2006/relationships">
   <p:cSld>
     <p:spTree>
@@ -1797,7 +1797,7 @@
 </p:sld>
 </file>
 
-<file path=ppt/slides/slide13.xml><?xml version="1.0" encoding="utf-8"?>
+<file path=ppt/slides/slide3.xml><?xml version="1.0" encoding="utf-8"?>
 <p:sld xmlns:a="http://schemas.openxmlformats.org/drawingml/2006/main" xmlns:p="http://schemas.openxmlformats.org/presentationml/2006/main" xmlns:r="http://schemas.openxmlformats.org/officeDocument/2006/relationships">
   <p:cSld>
     <p:spTree>
@@ -1839,7 +1839,7 @@
                   <a:srgbClr val="FFFFFF"/>
                 </a:solidFill>
               </a:rPr>
-              <a:t>Four lecture types each week</a:t>
+              <a:t>Four seminar types each week</a:t>
             </a:r>
             <a:endParaRPr lang="en-US" sz="3200" dirty="0"/>
           </a:p>
@@ -1994,7 +1994,7 @@
 </p:sld>
 </file>
 
-<file path=ppt/slides/slide14.xml><?xml version="1.0" encoding="utf-8"?>
+<file path=ppt/slides/slide4.xml><?xml version="1.0" encoding="utf-8"?>
 <p:sld xmlns:a="http://schemas.openxmlformats.org/drawingml/2006/main" xmlns:p="http://schemas.openxmlformats.org/presentationml/2006/main" xmlns:r="http://schemas.openxmlformats.org/officeDocument/2006/relationships">
   <p:cSld>
     <p:spTree>
@@ -2191,7 +2191,7 @@
 </p:sld>
 </file>
 
-<file path=ppt/slides/slide15.xml><?xml version="1.0" encoding="utf-8"?>
+<file path=ppt/slides/slide5.xml><?xml version="1.0" encoding="utf-8"?>
 <p:sld xmlns:a="http://schemas.openxmlformats.org/drawingml/2006/main" xmlns:p="http://schemas.openxmlformats.org/presentationml/2006/main" xmlns:r="http://schemas.openxmlformats.org/officeDocument/2006/relationships">
   <p:cSld>
     <p:spTree>
@@ -2388,7 +2388,7 @@
 </p:sld>
 </file>
 
-<file path=ppt/slides/slide16.xml><?xml version="1.0" encoding="utf-8"?>
+<file path=ppt/slides/slide6.xml><?xml version="1.0" encoding="utf-8"?>
 <p:sld xmlns:a="http://schemas.openxmlformats.org/drawingml/2006/main" xmlns:p="http://schemas.openxmlformats.org/presentationml/2006/main" xmlns:r="http://schemas.openxmlformats.org/officeDocument/2006/relationships">
   <p:cSld>
     <p:spTree>

</xml_diff>